<commit_message>
Update PowerPoint for song #250 in FUBC - Українські
</commit_message>
<xml_diff>
--- a/fubc-ua/250-Ніжно всіх Спаситель закликає (Пісні Спасенних №249).pptx
+++ b/fubc-ua/250-Ніжно всіх Спаситель закликає (Пісні Спасенних №249).pptx
@@ -685,7 +685,7 @@
           <a:p>
             <a:r>
               <a:rPr lang="en-US" dirty="0"/>
-              <a:t>P · 1/1 · rows:2,2,1,2</a:t>
+              <a:t>P · 1/1</a:t>
             </a:r>
             <a:endParaRPr lang="en-US" dirty="0"/>
           </a:p>
@@ -861,7 +861,7 @@
           <a:p>
             <a:r>
               <a:rPr lang="en-US" dirty="0"/>
-              <a:t>P · 1/1 · rows:2,2,1,2</a:t>
+              <a:t>P · 1/1</a:t>
             </a:r>
             <a:endParaRPr lang="en-US" dirty="0"/>
           </a:p>
@@ -1037,7 +1037,7 @@
           <a:p>
             <a:r>
               <a:rPr lang="en-US" dirty="0"/>
-              <a:t>P · 1/1 · rows:2,2,1,2</a:t>
+              <a:t>P · 1/1</a:t>
             </a:r>
             <a:endParaRPr lang="en-US" dirty="0"/>
           </a:p>
@@ -1741,7 +1741,7 @@
                 <a:ea typeface="Arial" pitchFamily="34" charset="-122"/>
                 <a:cs typeface="Arial" pitchFamily="34" charset="-120"/>
               </a:rPr>
-              <a:t>Боже мій (Боже мій),</a:t>
+              <a:t>Боже мій, дорогий,</a:t>
             </a:r>
             <a:endParaRPr lang="en-US" sz="5200" dirty="0"/>
           </a:p>
@@ -1758,7 +1758,7 @@
                 <a:ea typeface="Arial" pitchFamily="34" charset="-122"/>
                 <a:cs typeface="Arial" pitchFamily="34" charset="-120"/>
               </a:rPr>
-              <a:t>дорогий (дорогий),</a:t>
+              <a:t>я бажаю за Тобою йти.</a:t>
             </a:r>
             <a:endParaRPr lang="en-US" sz="5200" dirty="0"/>
           </a:p>
@@ -1775,7 +1775,7 @@
                 <a:ea typeface="Arial" pitchFamily="34" charset="-122"/>
                 <a:cs typeface="Arial" pitchFamily="34" charset="-120"/>
               </a:rPr>
-              <a:t>я бажаю за Тобою</a:t>
+              <a:t>Боже мій, дорогий,</a:t>
             </a:r>
             <a:endParaRPr lang="en-US" sz="5200" dirty="0"/>
           </a:p>
@@ -1792,58 +1792,7 @@
                 <a:ea typeface="Arial" pitchFamily="34" charset="-122"/>
                 <a:cs typeface="Arial" pitchFamily="34" charset="-120"/>
               </a:rPr>
-              <a:t>йти (бажаю йти).</a:t>
-            </a:r>
-            <a:endParaRPr lang="en-US" sz="5200" dirty="0"/>
-          </a:p>
-          <a:p>
-            <a:pPr algn="ctr" indent="0" marL="0">
-              <a:buNone/>
-            </a:pPr>
-            <a:r>
-              <a:rPr lang="en-US" sz="5200" b="1" i="1" dirty="0">
-                <a:solidFill>
-                  <a:srgbClr val="FFFFFF"/>
-                </a:solidFill>
-                <a:latin typeface="Arial" pitchFamily="34" charset="0"/>
-                <a:ea typeface="Arial" pitchFamily="34" charset="-122"/>
-                <a:cs typeface="Arial" pitchFamily="34" charset="-120"/>
-              </a:rPr>
-              <a:t>Боже мій (Боже мій), дорогий,</a:t>
-            </a:r>
-            <a:endParaRPr lang="en-US" sz="5200" dirty="0"/>
-          </a:p>
-          <a:p>
-            <a:pPr algn="ctr" indent="0" marL="0">
-              <a:buNone/>
-            </a:pPr>
-            <a:r>
-              <a:rPr lang="en-US" sz="5200" b="1" i="1" dirty="0">
-                <a:solidFill>
-                  <a:srgbClr val="FFFFFF"/>
-                </a:solidFill>
-                <a:latin typeface="Arial" pitchFamily="34" charset="0"/>
-                <a:ea typeface="Arial" pitchFamily="34" charset="-122"/>
-                <a:cs typeface="Arial" pitchFamily="34" charset="-120"/>
-              </a:rPr>
-              <a:t>я піду, куди вестимеш</a:t>
-            </a:r>
-            <a:endParaRPr lang="en-US" sz="5200" dirty="0"/>
-          </a:p>
-          <a:p>
-            <a:pPr algn="ctr" indent="0" marL="0">
-              <a:buNone/>
-            </a:pPr>
-            <a:r>
-              <a:rPr lang="en-US" sz="5200" b="1" i="1" dirty="0">
-                <a:solidFill>
-                  <a:srgbClr val="FFFFFF"/>
-                </a:solidFill>
-                <a:latin typeface="Arial" pitchFamily="34" charset="0"/>
-                <a:ea typeface="Arial" pitchFamily="34" charset="-122"/>
-                <a:cs typeface="Arial" pitchFamily="34" charset="-120"/>
-              </a:rPr>
-              <a:t>Ти (вестимеш Ти)!</a:t>
+              <a:t>я піду, куди вестимеш Ти!</a:t>
             </a:r>
             <a:endParaRPr lang="en-US" sz="5200" dirty="0"/>
           </a:p>
@@ -2053,7 +2002,7 @@
                 <a:ea typeface="Arial" pitchFamily="34" charset="-122"/>
                 <a:cs typeface="Arial" pitchFamily="34" charset="-120"/>
               </a:rPr>
-              <a:t>Боже мій (Боже мій),</a:t>
+              <a:t>Боже мій, дорогий,</a:t>
             </a:r>
             <a:endParaRPr lang="en-US" sz="5200" dirty="0"/>
           </a:p>
@@ -2070,7 +2019,7 @@
                 <a:ea typeface="Arial" pitchFamily="34" charset="-122"/>
                 <a:cs typeface="Arial" pitchFamily="34" charset="-120"/>
               </a:rPr>
-              <a:t>дорогий (дорогий),</a:t>
+              <a:t>я бажаю за Тобою йти.</a:t>
             </a:r>
             <a:endParaRPr lang="en-US" sz="5200" dirty="0"/>
           </a:p>
@@ -2087,7 +2036,7 @@
                 <a:ea typeface="Arial" pitchFamily="34" charset="-122"/>
                 <a:cs typeface="Arial" pitchFamily="34" charset="-120"/>
               </a:rPr>
-              <a:t>я бажаю за Тобою</a:t>
+              <a:t>Боже мій, дорогий,</a:t>
             </a:r>
             <a:endParaRPr lang="en-US" sz="5200" dirty="0"/>
           </a:p>
@@ -2104,58 +2053,7 @@
                 <a:ea typeface="Arial" pitchFamily="34" charset="-122"/>
                 <a:cs typeface="Arial" pitchFamily="34" charset="-120"/>
               </a:rPr>
-              <a:t>йти (бажаю йти).</a:t>
-            </a:r>
-            <a:endParaRPr lang="en-US" sz="5200" dirty="0"/>
-          </a:p>
-          <a:p>
-            <a:pPr algn="ctr" indent="0" marL="0">
-              <a:buNone/>
-            </a:pPr>
-            <a:r>
-              <a:rPr lang="en-US" sz="5200" b="1" i="1" dirty="0">
-                <a:solidFill>
-                  <a:srgbClr val="FFFFFF"/>
-                </a:solidFill>
-                <a:latin typeface="Arial" pitchFamily="34" charset="0"/>
-                <a:ea typeface="Arial" pitchFamily="34" charset="-122"/>
-                <a:cs typeface="Arial" pitchFamily="34" charset="-120"/>
-              </a:rPr>
-              <a:t>Боже мій (Боже мій), дорогий,</a:t>
-            </a:r>
-            <a:endParaRPr lang="en-US" sz="5200" dirty="0"/>
-          </a:p>
-          <a:p>
-            <a:pPr algn="ctr" indent="0" marL="0">
-              <a:buNone/>
-            </a:pPr>
-            <a:r>
-              <a:rPr lang="en-US" sz="5200" b="1" i="1" dirty="0">
-                <a:solidFill>
-                  <a:srgbClr val="FFFFFF"/>
-                </a:solidFill>
-                <a:latin typeface="Arial" pitchFamily="34" charset="0"/>
-                <a:ea typeface="Arial" pitchFamily="34" charset="-122"/>
-                <a:cs typeface="Arial" pitchFamily="34" charset="-120"/>
-              </a:rPr>
-              <a:t>я піду, куди вестимеш</a:t>
-            </a:r>
-            <a:endParaRPr lang="en-US" sz="5200" dirty="0"/>
-          </a:p>
-          <a:p>
-            <a:pPr algn="ctr" indent="0" marL="0">
-              <a:buNone/>
-            </a:pPr>
-            <a:r>
-              <a:rPr lang="en-US" sz="5200" b="1" i="1" dirty="0">
-                <a:solidFill>
-                  <a:srgbClr val="FFFFFF"/>
-                </a:solidFill>
-                <a:latin typeface="Arial" pitchFamily="34" charset="0"/>
-                <a:ea typeface="Arial" pitchFamily="34" charset="-122"/>
-                <a:cs typeface="Arial" pitchFamily="34" charset="-120"/>
-              </a:rPr>
-              <a:t>Ти (вестимеш Ти)!</a:t>
+              <a:t>я піду, куди вестимеш Ти!</a:t>
             </a:r>
             <a:endParaRPr lang="en-US" sz="5200" dirty="0"/>
           </a:p>
@@ -2365,7 +2263,7 @@
                 <a:ea typeface="Arial" pitchFamily="34" charset="-122"/>
                 <a:cs typeface="Arial" pitchFamily="34" charset="-120"/>
               </a:rPr>
-              <a:t>Боже мій (Боже мій),</a:t>
+              <a:t>Боже мій, дорогий,</a:t>
             </a:r>
             <a:endParaRPr lang="en-US" sz="5200" dirty="0"/>
           </a:p>
@@ -2382,7 +2280,7 @@
                 <a:ea typeface="Arial" pitchFamily="34" charset="-122"/>
                 <a:cs typeface="Arial" pitchFamily="34" charset="-120"/>
               </a:rPr>
-              <a:t>дорогий (дорогий),</a:t>
+              <a:t>я бажаю за Тобою йти.</a:t>
             </a:r>
             <a:endParaRPr lang="en-US" sz="5200" dirty="0"/>
           </a:p>
@@ -2399,7 +2297,7 @@
                 <a:ea typeface="Arial" pitchFamily="34" charset="-122"/>
                 <a:cs typeface="Arial" pitchFamily="34" charset="-120"/>
               </a:rPr>
-              <a:t>я бажаю за Тобою</a:t>
+              <a:t>Боже мій, дорогий,</a:t>
             </a:r>
             <a:endParaRPr lang="en-US" sz="5200" dirty="0"/>
           </a:p>
@@ -2416,58 +2314,7 @@
                 <a:ea typeface="Arial" pitchFamily="34" charset="-122"/>
                 <a:cs typeface="Arial" pitchFamily="34" charset="-120"/>
               </a:rPr>
-              <a:t>йти (бажаю йти).</a:t>
-            </a:r>
-            <a:endParaRPr lang="en-US" sz="5200" dirty="0"/>
-          </a:p>
-          <a:p>
-            <a:pPr algn="ctr" indent="0" marL="0">
-              <a:buNone/>
-            </a:pPr>
-            <a:r>
-              <a:rPr lang="en-US" sz="5200" b="1" i="1" dirty="0">
-                <a:solidFill>
-                  <a:srgbClr val="FFFFFF"/>
-                </a:solidFill>
-                <a:latin typeface="Arial" pitchFamily="34" charset="0"/>
-                <a:ea typeface="Arial" pitchFamily="34" charset="-122"/>
-                <a:cs typeface="Arial" pitchFamily="34" charset="-120"/>
-              </a:rPr>
-              <a:t>Боже мій (Боже мій), дорогий,</a:t>
-            </a:r>
-            <a:endParaRPr lang="en-US" sz="5200" dirty="0"/>
-          </a:p>
-          <a:p>
-            <a:pPr algn="ctr" indent="0" marL="0">
-              <a:buNone/>
-            </a:pPr>
-            <a:r>
-              <a:rPr lang="en-US" sz="5200" b="1" i="1" dirty="0">
-                <a:solidFill>
-                  <a:srgbClr val="FFFFFF"/>
-                </a:solidFill>
-                <a:latin typeface="Arial" pitchFamily="34" charset="0"/>
-                <a:ea typeface="Arial" pitchFamily="34" charset="-122"/>
-                <a:cs typeface="Arial" pitchFamily="34" charset="-120"/>
-              </a:rPr>
-              <a:t>я піду, куди вестимеш</a:t>
-            </a:r>
-            <a:endParaRPr lang="en-US" sz="5200" dirty="0"/>
-          </a:p>
-          <a:p>
-            <a:pPr algn="ctr" indent="0" marL="0">
-              <a:buNone/>
-            </a:pPr>
-            <a:r>
-              <a:rPr lang="en-US" sz="5200" b="1" i="1" dirty="0">
-                <a:solidFill>
-                  <a:srgbClr val="FFFFFF"/>
-                </a:solidFill>
-                <a:latin typeface="Arial" pitchFamily="34" charset="0"/>
-                <a:ea typeface="Arial" pitchFamily="34" charset="-122"/>
-                <a:cs typeface="Arial" pitchFamily="34" charset="-120"/>
-              </a:rPr>
-              <a:t>Ти (вестимеш Ти)!</a:t>
+              <a:t>я піду, куди вестимеш Ти!</a:t>
             </a:r>
             <a:endParaRPr lang="en-US" sz="5200" dirty="0"/>
           </a:p>

</xml_diff>